<commit_message>
Finalize presentation and presentation notes
</commit_message>
<xml_diff>
--- a/presentation/STT-DB_Praesentation.pptx
+++ b/presentation/STT-DB_Praesentation.pptx
@@ -1943,45 +1943,6 @@
       </p:sp>
       <p:sp>
         <p:nvSpPr>
-          <p:cNvPr id="9" name="Text 6"/>
-          <p:cNvSpPr/>
-          <p:nvPr/>
-        </p:nvSpPr>
-        <p:spPr>
-          <a:xfrm>
-            <a:off x="6492240" y="6519672"/>
-            <a:ext cx="2148840" cy="164592"/>
-          </a:xfrm>
-          <a:prstGeom prst="rect">
-            <a:avLst/>
-          </a:prstGeom>
-          <a:noFill/>
-          <a:ln/>
-        </p:spPr>
-        <p:txBody>
-          <a:bodyPr wrap="square" lIns="0" tIns="0" rIns="0" bIns="0" rtlCol="0" anchor="ctr"/>
-          <a:lstStyle/>
-          <a:p>
-            <a:pPr marL="0" indent="0" algn="r">
-              <a:buNone/>
-            </a:pPr>
-            <a:r>
-              <a:rPr lang="de-CH" sz="850" b="1" dirty="0">
-                <a:solidFill>
-                  <a:srgbClr val="FFFFFF"/>
-                </a:solidFill>
-                <a:latin typeface="Arial" pitchFamily="34" charset="0"/>
-                <a:ea typeface="Arial" pitchFamily="34" charset="-122"/>
-                <a:cs typeface="Arial" pitchFamily="34" charset="-120"/>
-              </a:rPr>
-              <a:t>MORE THAN A GAME</a:t>
-            </a:r>
-            <a:endParaRPr lang="de-CH" sz="850" dirty="0"/>
-          </a:p>
-        </p:txBody>
-      </p:sp>
-      <p:sp>
-        <p:nvSpPr>
           <p:cNvPr id="10" name="Text 7"/>
           <p:cNvSpPr/>
           <p:nvPr/>
@@ -2896,45 +2857,6 @@
       </p:sp>
       <p:sp>
         <p:nvSpPr>
-          <p:cNvPr id="9" name="Text 6"/>
-          <p:cNvSpPr/>
-          <p:nvPr/>
-        </p:nvSpPr>
-        <p:spPr>
-          <a:xfrm>
-            <a:off x="6492240" y="6519672"/>
-            <a:ext cx="2148840" cy="164592"/>
-          </a:xfrm>
-          <a:prstGeom prst="rect">
-            <a:avLst/>
-          </a:prstGeom>
-          <a:noFill/>
-          <a:ln/>
-        </p:spPr>
-        <p:txBody>
-          <a:bodyPr wrap="square" lIns="0" tIns="0" rIns="0" bIns="0" rtlCol="0" anchor="ctr"/>
-          <a:lstStyle/>
-          <a:p>
-            <a:pPr marL="0" indent="0" algn="r">
-              <a:buNone/>
-            </a:pPr>
-            <a:r>
-              <a:rPr lang="de-CH" sz="850" b="1" dirty="0">
-                <a:solidFill>
-                  <a:srgbClr val="FFFFFF"/>
-                </a:solidFill>
-                <a:latin typeface="Arial" pitchFamily="34" charset="0"/>
-                <a:ea typeface="Arial" pitchFamily="34" charset="-122"/>
-                <a:cs typeface="Arial" pitchFamily="34" charset="-120"/>
-              </a:rPr>
-              <a:t>MORE THAN A GAME</a:t>
-            </a:r>
-            <a:endParaRPr lang="de-CH" sz="850" dirty="0"/>
-          </a:p>
-        </p:txBody>
-      </p:sp>
-      <p:sp>
-        <p:nvSpPr>
           <p:cNvPr id="10" name="Text 7"/>
           <p:cNvSpPr/>
           <p:nvPr/>
@@ -4200,45 +4122,6 @@
       </p:sp>
       <p:sp>
         <p:nvSpPr>
-          <p:cNvPr id="9" name="Text 6"/>
-          <p:cNvSpPr/>
-          <p:nvPr/>
-        </p:nvSpPr>
-        <p:spPr>
-          <a:xfrm>
-            <a:off x="6492240" y="6519672"/>
-            <a:ext cx="2148840" cy="164592"/>
-          </a:xfrm>
-          <a:prstGeom prst="rect">
-            <a:avLst/>
-          </a:prstGeom>
-          <a:noFill/>
-          <a:ln/>
-        </p:spPr>
-        <p:txBody>
-          <a:bodyPr wrap="square" lIns="0" tIns="0" rIns="0" bIns="0" rtlCol="0" anchor="ctr"/>
-          <a:lstStyle/>
-          <a:p>
-            <a:pPr marL="0" indent="0" algn="r">
-              <a:buNone/>
-            </a:pPr>
-            <a:r>
-              <a:rPr lang="de-CH" sz="850" b="1" dirty="0">
-                <a:solidFill>
-                  <a:srgbClr val="FFFFFF"/>
-                </a:solidFill>
-                <a:latin typeface="Arial" pitchFamily="34" charset="0"/>
-                <a:ea typeface="Arial" pitchFamily="34" charset="-122"/>
-                <a:cs typeface="Arial" pitchFamily="34" charset="-120"/>
-              </a:rPr>
-              <a:t>MORE THAN A GAME</a:t>
-            </a:r>
-            <a:endParaRPr lang="de-CH" sz="850" dirty="0"/>
-          </a:p>
-        </p:txBody>
-      </p:sp>
-      <p:sp>
-        <p:nvSpPr>
           <p:cNvPr id="10" name="Text 7"/>
           <p:cNvSpPr/>
           <p:nvPr/>
@@ -5138,45 +5021,6 @@
       </p:sp>
       <p:sp>
         <p:nvSpPr>
-          <p:cNvPr id="9" name="Text 6"/>
-          <p:cNvSpPr/>
-          <p:nvPr/>
-        </p:nvSpPr>
-        <p:spPr>
-          <a:xfrm>
-            <a:off x="6492240" y="6519672"/>
-            <a:ext cx="2148840" cy="164592"/>
-          </a:xfrm>
-          <a:prstGeom prst="rect">
-            <a:avLst/>
-          </a:prstGeom>
-          <a:noFill/>
-          <a:ln/>
-        </p:spPr>
-        <p:txBody>
-          <a:bodyPr wrap="square" lIns="0" tIns="0" rIns="0" bIns="0" rtlCol="0" anchor="ctr"/>
-          <a:lstStyle/>
-          <a:p>
-            <a:pPr marL="0" indent="0" algn="r">
-              <a:buNone/>
-            </a:pPr>
-            <a:r>
-              <a:rPr lang="de-CH" sz="850" b="1" dirty="0">
-                <a:solidFill>
-                  <a:srgbClr val="FFFFFF"/>
-                </a:solidFill>
-                <a:latin typeface="Arial" pitchFamily="34" charset="0"/>
-                <a:ea typeface="Arial" pitchFamily="34" charset="-122"/>
-                <a:cs typeface="Arial" pitchFamily="34" charset="-120"/>
-              </a:rPr>
-              <a:t>MORE THAN A GAME</a:t>
-            </a:r>
-            <a:endParaRPr lang="de-CH" sz="850" dirty="0"/>
-          </a:p>
-        </p:txBody>
-      </p:sp>
-      <p:sp>
-        <p:nvSpPr>
           <p:cNvPr id="10" name="Text 7"/>
           <p:cNvSpPr/>
           <p:nvPr/>
@@ -6234,45 +6078,6 @@
       </p:sp>
       <p:sp>
         <p:nvSpPr>
-          <p:cNvPr id="9" name="Text 6"/>
-          <p:cNvSpPr/>
-          <p:nvPr/>
-        </p:nvSpPr>
-        <p:spPr>
-          <a:xfrm>
-            <a:off x="6492240" y="6519672"/>
-            <a:ext cx="2148840" cy="164592"/>
-          </a:xfrm>
-          <a:prstGeom prst="rect">
-            <a:avLst/>
-          </a:prstGeom>
-          <a:noFill/>
-          <a:ln/>
-        </p:spPr>
-        <p:txBody>
-          <a:bodyPr wrap="square" lIns="0" tIns="0" rIns="0" bIns="0" rtlCol="0" anchor="ctr"/>
-          <a:lstStyle/>
-          <a:p>
-            <a:pPr marL="0" indent="0" algn="r">
-              <a:buNone/>
-            </a:pPr>
-            <a:r>
-              <a:rPr lang="de-CH" sz="850" b="1" dirty="0">
-                <a:solidFill>
-                  <a:srgbClr val="FFFFFF"/>
-                </a:solidFill>
-                <a:latin typeface="Arial" pitchFamily="34" charset="0"/>
-                <a:ea typeface="Arial" pitchFamily="34" charset="-122"/>
-                <a:cs typeface="Arial" pitchFamily="34" charset="-120"/>
-              </a:rPr>
-              <a:t>MORE THAN A GAME</a:t>
-            </a:r>
-            <a:endParaRPr lang="de-CH" sz="850" dirty="0"/>
-          </a:p>
-        </p:txBody>
-      </p:sp>
-      <p:sp>
-        <p:nvSpPr>
           <p:cNvPr id="10" name="Text 7"/>
           <p:cNvSpPr/>
           <p:nvPr/>
@@ -7115,45 +6920,6 @@
                 <a:cs typeface="Arial" pitchFamily="34" charset="-120"/>
               </a:rPr>
               <a:t>Christian Abbühl · B-TIP-24-T-a · 21.09.2026</a:t>
-            </a:r>
-            <a:endParaRPr lang="de-CH" sz="850" dirty="0"/>
-          </a:p>
-        </p:txBody>
-      </p:sp>
-      <p:sp>
-        <p:nvSpPr>
-          <p:cNvPr id="9" name="Text 6"/>
-          <p:cNvSpPr/>
-          <p:nvPr/>
-        </p:nvSpPr>
-        <p:spPr>
-          <a:xfrm>
-            <a:off x="6492240" y="6519672"/>
-            <a:ext cx="2148840" cy="164592"/>
-          </a:xfrm>
-          <a:prstGeom prst="rect">
-            <a:avLst/>
-          </a:prstGeom>
-          <a:noFill/>
-          <a:ln/>
-        </p:spPr>
-        <p:txBody>
-          <a:bodyPr wrap="square" lIns="0" tIns="0" rIns="0" bIns="0" rtlCol="0" anchor="ctr"/>
-          <a:lstStyle/>
-          <a:p>
-            <a:pPr marL="0" indent="0" algn="r">
-              <a:buNone/>
-            </a:pPr>
-            <a:r>
-              <a:rPr lang="de-CH" sz="850" b="1" dirty="0">
-                <a:solidFill>
-                  <a:srgbClr val="FFFFFF"/>
-                </a:solidFill>
-                <a:latin typeface="Arial" pitchFamily="34" charset="0"/>
-                <a:ea typeface="Arial" pitchFamily="34" charset="-122"/>
-                <a:cs typeface="Arial" pitchFamily="34" charset="-120"/>
-              </a:rPr>
-              <a:t>MORE THAN A GAME</a:t>
             </a:r>
             <a:endParaRPr lang="de-CH" sz="850" dirty="0"/>
           </a:p>

</xml_diff>